<commit_message>
docs(marketing): bascule les assets sur le domaine syllabix.net
One-pager, pitch deck (régénéré) et générateur mis à jour avec syllabix.net.

Co-Authored-By: Claude Opus 4.8 <noreply@anthropic.com>
</commit_message>
<xml_diff>
--- a/docs/marketing/Syllabix-pitch-deck.pptx
+++ b/docs/marketing/Syllabix-pitch-deck.pptx
@@ -2197,7 +2197,7 @@
                 <a:ea typeface="Calibri" pitchFamily="34" charset="-122"/>
                 <a:cs typeface="Calibri" pitchFamily="34" charset="-120"/>
               </a:rPr>
-              <a:t>syllabix-eight.vercel.app</a:t>
+              <a:t>syllabix.net</a:t>
             </a:r>
             <a:endParaRPr lang="en-US" sz="1300" dirty="0"/>
           </a:p>
@@ -2965,7 +2965,7 @@
                 <a:ea typeface="Calibri" pitchFamily="34" charset="-122"/>
                 <a:cs typeface="Calibri" pitchFamily="34" charset="-120"/>
               </a:rPr>
-              <a:t>syllabix-eight.vercel.app</a:t>
+              <a:t>syllabix.net</a:t>
             </a:r>
             <a:endParaRPr lang="en-US" sz="1700" dirty="0"/>
           </a:p>

</xml_diff>